<commit_message>
Implement execution mode toggle for orchestrator jobs
Added backend and frontend support for setting execution mode ('claude_code' or 'multi_terminal') on orchestrator jobs. The execution mode is now stored in job metadata via a new API endpoint and is used by MCP tools to return mode-specific instructions and team roster. Cleaned up documentation and removed legacy references to deprecated git and task template tools. Added handover documentation for related cleanup and implementation steps.
</commit_message>
<xml_diff>
--- a/handovers/Reference_docs/giljoai workflow.pptx
+++ b/handovers/Reference_docs/giljoai workflow.pptx
@@ -234,7 +234,7 @@
           <a:p>
             <a:fld id="{416C67DE-CFD7-4293-887A-6877041E4FFC}" type="datetimeFigureOut">
               <a:rPr lang="en-US" smtClean="0"/>
-              <a:t>11/18/2025</a:t>
+              <a:t>11/29/2025</a:t>
             </a:fld>
             <a:endParaRPr lang="en-US"/>
           </a:p>
@@ -648,7 +648,7 @@
           <a:p>
             <a:fld id="{ED9B7CB9-CB20-4E51-B0CA-42467449EB46}" type="datetime1">
               <a:rPr lang="en-US" smtClean="0"/>
-              <a:t>11/18/2025</a:t>
+              <a:t>11/29/2025</a:t>
             </a:fld>
             <a:endParaRPr lang="en-US"/>
           </a:p>
@@ -846,7 +846,7 @@
           <a:p>
             <a:fld id="{8CC60638-A82E-46CE-BC0C-48D35FB3C658}" type="datetime1">
               <a:rPr lang="en-US" smtClean="0"/>
-              <a:t>11/18/2025</a:t>
+              <a:t>11/29/2025</a:t>
             </a:fld>
             <a:endParaRPr lang="en-US"/>
           </a:p>
@@ -1054,7 +1054,7 @@
           <a:p>
             <a:fld id="{B6029D30-CC6F-48F3-8489-7CBFA664EED5}" type="datetime1">
               <a:rPr lang="en-US" smtClean="0"/>
-              <a:t>11/18/2025</a:t>
+              <a:t>11/29/2025</a:t>
             </a:fld>
             <a:endParaRPr lang="en-US"/>
           </a:p>
@@ -1252,7 +1252,7 @@
           <a:p>
             <a:fld id="{6C9E7DF4-3877-4BFE-B5C4-861B9A235AD6}" type="datetime1">
               <a:rPr lang="en-US" smtClean="0"/>
-              <a:t>11/18/2025</a:t>
+              <a:t>11/29/2025</a:t>
             </a:fld>
             <a:endParaRPr lang="en-US"/>
           </a:p>
@@ -1537,7 +1537,7 @@
           <a:p>
             <a:fld id="{FE5AE3B2-C9E6-4BBD-A24E-B1D23E88ACAD}" type="datetime1">
               <a:rPr lang="en-US" smtClean="0"/>
-              <a:t>11/18/2025</a:t>
+              <a:t>11/29/2025</a:t>
             </a:fld>
             <a:endParaRPr lang="en-US"/>
           </a:p>
@@ -1802,7 +1802,7 @@
           <a:p>
             <a:fld id="{5980A91E-44C5-48EF-AB9E-C9EE62A71141}" type="datetime1">
               <a:rPr lang="en-US" smtClean="0"/>
-              <a:t>11/18/2025</a:t>
+              <a:t>11/29/2025</a:t>
             </a:fld>
             <a:endParaRPr lang="en-US"/>
           </a:p>
@@ -2214,7 +2214,7 @@
           <a:p>
             <a:fld id="{B2530319-9480-423F-A385-59E530B00954}" type="datetime1">
               <a:rPr lang="en-US" smtClean="0"/>
-              <a:t>11/18/2025</a:t>
+              <a:t>11/29/2025</a:t>
             </a:fld>
             <a:endParaRPr lang="en-US"/>
           </a:p>
@@ -2355,7 +2355,7 @@
           <a:p>
             <a:fld id="{A2362125-4BC4-4B6E-951B-5A8C76AD041F}" type="datetime1">
               <a:rPr lang="en-US" smtClean="0"/>
-              <a:t>11/18/2025</a:t>
+              <a:t>11/29/2025</a:t>
             </a:fld>
             <a:endParaRPr lang="en-US"/>
           </a:p>
@@ -2468,7 +2468,7 @@
           <a:p>
             <a:fld id="{540900B7-0B4F-478F-94C9-ACD28367F078}" type="datetime1">
               <a:rPr lang="en-US" smtClean="0"/>
-              <a:t>11/18/2025</a:t>
+              <a:t>11/29/2025</a:t>
             </a:fld>
             <a:endParaRPr lang="en-US"/>
           </a:p>
@@ -2779,7 +2779,7 @@
           <a:p>
             <a:fld id="{8688C4A6-149A-4F56-BCC7-939EECDCA4D5}" type="datetime1">
               <a:rPr lang="en-US" smtClean="0"/>
-              <a:t>11/18/2025</a:t>
+              <a:t>11/29/2025</a:t>
             </a:fld>
             <a:endParaRPr lang="en-US"/>
           </a:p>
@@ -3067,7 +3067,7 @@
           <a:p>
             <a:fld id="{04FA1CE9-15F9-4F43-A295-F3BC07C72081}" type="datetime1">
               <a:rPr lang="en-US" smtClean="0"/>
-              <a:t>11/18/2025</a:t>
+              <a:t>11/29/2025</a:t>
             </a:fld>
             <a:endParaRPr lang="en-US"/>
           </a:p>
@@ -3308,7 +3308,7 @@
           <a:p>
             <a:fld id="{BA3D8D1C-4A3B-4F03-A778-92E4AFA91CAB}" type="datetime1">
               <a:rPr lang="en-US" smtClean="0"/>
-              <a:t>11/18/2025</a:t>
+              <a:t>11/29/2025</a:t>
             </a:fld>
             <a:endParaRPr lang="en-US"/>
           </a:p>
@@ -21861,7 +21861,7 @@
             <a:pPr algn="ctr"/>
             <a:r>
               <a:rPr lang="en-US" dirty="0"/>
-              <a:t>Button creates dynamic “system prompt” for copy and paste into a terminal running  Agentic AI coding tool so it can stage the job for the project</a:t>
+              <a:t>Button creates “prompt” for copy and paste into a terminal running  Agentic AI coding tool so it can stage the job for the project</a:t>
             </a:r>
           </a:p>
         </p:txBody>
@@ -21927,8 +21927,8 @@
         </p:nvSpPr>
         <p:spPr>
           <a:xfrm>
-            <a:off x="3256775" y="5220811"/>
-            <a:ext cx="2288337" cy="1494096"/>
+            <a:off x="3256775" y="4965192"/>
+            <a:ext cx="2288337" cy="1749715"/>
           </a:xfrm>
           <a:prstGeom prst="roundRect">
             <a:avLst/>
@@ -21955,7 +21955,7 @@
             <a:pPr algn="ctr"/>
             <a:r>
               <a:rPr lang="en-US" dirty="0"/>
-              <a:t>Agentic CLI tool becomes “Orchestrator” Agent and executes prompt instructions</a:t>
+              <a:t>Agentic CLI tool becomes “Orchestrator” Agent and reads instructions on MCP server</a:t>
             </a:r>
           </a:p>
         </p:txBody>
@@ -21974,8 +21974,8 @@
         </p:nvSpPr>
         <p:spPr>
           <a:xfrm>
-            <a:off x="3255706" y="2484865"/>
-            <a:ext cx="2288337" cy="2072595"/>
+            <a:off x="3255706" y="2240281"/>
+            <a:ext cx="2288337" cy="2317180"/>
           </a:xfrm>
           <a:prstGeom prst="roundRect">
             <a:avLst/>
@@ -22002,7 +22002,7 @@
             <a:pPr algn="ctr"/>
             <a:r>
               <a:rPr lang="en-US" dirty="0"/>
-              <a:t>Orchestrator reads contexts and sources material available via MCP commands see Slide 8,9,11,14,17,18,20</a:t>
+              <a:t>MCP instructions say to read contexts and sources material available via MCP commands see Slide 8,9,11,14,17,18,20</a:t>
             </a:r>
           </a:p>
         </p:txBody>
@@ -22318,8 +22318,8 @@
         </p:nvCxnSpPr>
         <p:spPr>
           <a:xfrm rot="16200000" flipV="1">
-            <a:off x="4068735" y="4888601"/>
-            <a:ext cx="663351" cy="1069"/>
+            <a:off x="4196545" y="4760792"/>
+            <a:ext cx="407731" cy="1069"/>
           </a:xfrm>
           <a:prstGeom prst="bentConnector3">
             <a:avLst>
@@ -22363,8 +22363,8 @@
         </p:nvCxnSpPr>
         <p:spPr>
           <a:xfrm rot="5400000" flipH="1" flipV="1">
-            <a:off x="4911135" y="1365657"/>
-            <a:ext cx="607948" cy="1630468"/>
+            <a:off x="5033427" y="1243365"/>
+            <a:ext cx="363364" cy="1630468"/>
           </a:xfrm>
           <a:prstGeom prst="bentConnector2">
             <a:avLst/>
@@ -22870,7 +22870,7 @@
         </p:nvSpPr>
         <p:spPr>
           <a:xfrm>
-            <a:off x="3962397" y="1828800"/>
+            <a:off x="3880940" y="1781486"/>
             <a:ext cx="3813493" cy="1162198"/>
           </a:xfrm>
           <a:prstGeom prst="roundRect">
@@ -22898,7 +22898,7 @@
             <a:pPr algn="ctr"/>
             <a:r>
               <a:rPr lang="en-US" dirty="0"/>
-              <a:t>Implementation window orchestrator with Toggle option for “Claude Code CLI” or “Legacy CLI coding mode”</a:t>
+              <a:t>Moves to implementation window with Toggle option for “Claude Code CLI” or “General CLI coding mode”</a:t>
             </a:r>
           </a:p>
         </p:txBody>
@@ -23015,8 +23015,8 @@
         </p:nvCxnSpPr>
         <p:spPr>
           <a:xfrm flipV="1">
-            <a:off x="3524978" y="2409899"/>
-            <a:ext cx="437419" cy="13960"/>
+            <a:off x="3524978" y="2362585"/>
+            <a:ext cx="355962" cy="61274"/>
           </a:xfrm>
           <a:prstGeom prst="straightConnector1">
             <a:avLst/>
@@ -23152,60 +23152,6 @@
       </p:sp>
       <p:sp>
         <p:nvSpPr>
-          <p:cNvPr id="30" name="Rectangle: Rounded Corners 29">
-            <a:extLst>
-              <a:ext uri="{FF2B5EF4-FFF2-40B4-BE49-F238E27FC236}">
-                <a16:creationId xmlns:a16="http://schemas.microsoft.com/office/drawing/2014/main" id="{8A0C8649-33AA-A8E6-63DD-928061CC5EF7}"/>
-              </a:ext>
-            </a:extLst>
-          </p:cNvPr>
-          <p:cNvSpPr/>
-          <p:nvPr/>
-        </p:nvSpPr>
-        <p:spPr>
-          <a:xfrm>
-            <a:off x="477178" y="4448766"/>
-            <a:ext cx="3813493" cy="963260"/>
-          </a:xfrm>
-          <a:prstGeom prst="roundRect">
-            <a:avLst/>
-          </a:prstGeom>
-        </p:spPr>
-        <p:style>
-          <a:lnRef idx="2">
-            <a:schemeClr val="dk1"/>
-          </a:lnRef>
-          <a:fillRef idx="1">
-            <a:schemeClr val="lt1"/>
-          </a:fillRef>
-          <a:effectRef idx="0">
-            <a:schemeClr val="dk1"/>
-          </a:effectRef>
-          <a:fontRef idx="minor">
-            <a:schemeClr val="dk1"/>
-          </a:fontRef>
-        </p:style>
-        <p:txBody>
-          <a:bodyPr lIns="0" tIns="0" rIns="0" bIns="0" rtlCol="0" anchor="t"/>
-          <a:lstStyle/>
-          <a:p>
-            <a:pPr algn="ctr"/>
-            <a:r>
-              <a:rPr lang="en-US" dirty="0"/>
-              <a:t>Orchestrator prompt button for Claude Code is enabled. </a:t>
-            </a:r>
-          </a:p>
-          <a:p>
-            <a:pPr algn="ctr"/>
-            <a:r>
-              <a:rPr lang="en-US" dirty="0"/>
-              <a:t>Legacy CLI Prompt is disabled. </a:t>
-            </a:r>
-          </a:p>
-        </p:txBody>
-      </p:sp>
-      <p:sp>
-        <p:nvSpPr>
           <p:cNvPr id="31" name="Rectangle: Rounded Corners 30">
             <a:extLst>
               <a:ext uri="{FF2B5EF4-FFF2-40B4-BE49-F238E27FC236}">
@@ -23312,8 +23258,8 @@
         </p:nvSpPr>
         <p:spPr>
           <a:xfrm>
-            <a:off x="592731" y="5687466"/>
-            <a:ext cx="3813493" cy="963260"/>
+            <a:off x="151775" y="4683142"/>
+            <a:ext cx="3813493" cy="1909681"/>
           </a:xfrm>
           <a:prstGeom prst="roundRect">
             <a:avLst/>
@@ -23340,7 +23286,7 @@
             <a:pPr algn="ctr"/>
             <a:r>
               <a:rPr lang="en-US" dirty="0"/>
-              <a:t>Orchestrator prompt instructs it to assign the staged generated jobs to subagents</a:t>
+              <a:t>Orchestrator prompt says to fetch instructions on MCP server, instructions instructs Orchestrator  to spawn agents, either in parallel or sequential based on orchestrator decision.</a:t>
             </a:r>
           </a:p>
         </p:txBody>
@@ -23387,7 +23333,7 @@
             <a:pPr algn="ctr"/>
             <a:r>
               <a:rPr lang="en-US" dirty="0"/>
-              <a:t>User copes and pastes prompt in Singular terminal window work</a:t>
+              <a:t>User copes and pastes prompt in one terminal window </a:t>
             </a:r>
           </a:p>
         </p:txBody>
@@ -23407,7 +23353,7 @@
         <p:spPr>
           <a:xfrm>
             <a:off x="9615740" y="326763"/>
-            <a:ext cx="2133018" cy="1314878"/>
+            <a:ext cx="2133018" cy="1003163"/>
           </a:xfrm>
           <a:prstGeom prst="roundRect">
             <a:avLst/>
@@ -23434,54 +23380,7 @@
             <a:pPr algn="ctr"/>
             <a:r>
               <a:rPr lang="en-US" dirty="0"/>
-              <a:t>Orchestrator Legacy Cli mode prompt button is activated (this is default)</a:t>
-            </a:r>
-          </a:p>
-        </p:txBody>
-      </p:sp>
-      <p:sp>
-        <p:nvSpPr>
-          <p:cNvPr id="43" name="Rectangle: Rounded Corners 42">
-            <a:extLst>
-              <a:ext uri="{FF2B5EF4-FFF2-40B4-BE49-F238E27FC236}">
-                <a16:creationId xmlns:a16="http://schemas.microsoft.com/office/drawing/2014/main" id="{B9DFB2F2-2F57-C8C2-A5B6-857269547A5E}"/>
-              </a:ext>
-            </a:extLst>
-          </p:cNvPr>
-          <p:cNvSpPr/>
-          <p:nvPr/>
-        </p:nvSpPr>
-        <p:spPr>
-          <a:xfrm>
-            <a:off x="9720441" y="3634296"/>
-            <a:ext cx="2133018" cy="1497811"/>
-          </a:xfrm>
-          <a:prstGeom prst="roundRect">
-            <a:avLst/>
-          </a:prstGeom>
-        </p:spPr>
-        <p:style>
-          <a:lnRef idx="2">
-            <a:schemeClr val="dk1"/>
-          </a:lnRef>
-          <a:fillRef idx="1">
-            <a:schemeClr val="lt1"/>
-          </a:fillRef>
-          <a:effectRef idx="0">
-            <a:schemeClr val="dk1"/>
-          </a:effectRef>
-          <a:fontRef idx="minor">
-            <a:schemeClr val="dk1"/>
-          </a:fontRef>
-        </p:style>
-        <p:txBody>
-          <a:bodyPr lIns="0" tIns="0" rIns="0" bIns="0" rtlCol="0" anchor="t"/>
-          <a:lstStyle/>
-          <a:p>
-            <a:pPr algn="ctr"/>
-            <a:r>
-              <a:rPr lang="en-US" dirty="0"/>
-              <a:t>Orchestrator, after determination from above unlocks individual prompt buttons</a:t>
+              <a:t>Orchestrator general Cli mode activated (this is default)</a:t>
             </a:r>
           </a:p>
         </p:txBody>
@@ -23529,53 +23428,6 @@
             <a:r>
               <a:rPr lang="en-US" dirty="0"/>
               <a:t>User copies each prompt to a unique terminal window to start agents work</a:t>
-            </a:r>
-          </a:p>
-        </p:txBody>
-      </p:sp>
-      <p:sp>
-        <p:nvSpPr>
-          <p:cNvPr id="48" name="Rectangle: Rounded Corners 47">
-            <a:extLst>
-              <a:ext uri="{FF2B5EF4-FFF2-40B4-BE49-F238E27FC236}">
-                <a16:creationId xmlns:a16="http://schemas.microsoft.com/office/drawing/2014/main" id="{540B32F0-C701-100D-3B2A-204575A54277}"/>
-              </a:ext>
-            </a:extLst>
-          </p:cNvPr>
-          <p:cNvSpPr/>
-          <p:nvPr/>
-        </p:nvSpPr>
-        <p:spPr>
-          <a:xfrm>
-            <a:off x="9406916" y="1902484"/>
-            <a:ext cx="2613487" cy="1497810"/>
-          </a:xfrm>
-          <a:prstGeom prst="roundRect">
-            <a:avLst/>
-          </a:prstGeom>
-        </p:spPr>
-        <p:style>
-          <a:lnRef idx="2">
-            <a:schemeClr val="dk1"/>
-          </a:lnRef>
-          <a:fillRef idx="1">
-            <a:schemeClr val="lt1"/>
-          </a:fillRef>
-          <a:effectRef idx="0">
-            <a:schemeClr val="dk1"/>
-          </a:effectRef>
-          <a:fontRef idx="minor">
-            <a:schemeClr val="dk1"/>
-          </a:fontRef>
-        </p:style>
-        <p:txBody>
-          <a:bodyPr lIns="0" tIns="0" rIns="0" bIns="0" rtlCol="0" anchor="t"/>
-          <a:lstStyle/>
-          <a:p>
-            <a:pPr algn="ctr"/>
-            <a:r>
-              <a:rPr lang="en-US" dirty="0"/>
-              <a:t>User instructed to launch orchestrator first, to determine parallel or sequential agent use for the project</a:t>
             </a:r>
           </a:p>
         </p:txBody>
@@ -23597,8 +23449,8 @@
         </p:nvCxnSpPr>
         <p:spPr>
           <a:xfrm>
-            <a:off x="7775890" y="2409899"/>
-            <a:ext cx="186134" cy="13960"/>
+            <a:off x="7694433" y="2362585"/>
+            <a:ext cx="267591" cy="61274"/>
           </a:xfrm>
           <a:prstGeom prst="bentConnector3">
             <a:avLst/>
@@ -23674,6 +23526,7 @@
             </a:extLst>
           </p:cNvPr>
           <p:cNvCxnSpPr>
+            <a:cxnSpLocks/>
             <a:stCxn id="27" idx="0"/>
             <a:endCxn id="41" idx="1"/>
           </p:cNvCxnSpPr>
@@ -23681,8 +23534,8 @@
         </p:nvCxnSpPr>
         <p:spPr>
           <a:xfrm rot="5400000" flipH="1" flipV="1">
-            <a:off x="8930709" y="644896"/>
-            <a:ext cx="345724" cy="1024337"/>
+            <a:off x="8852781" y="566968"/>
+            <a:ext cx="501581" cy="1024337"/>
           </a:xfrm>
           <a:prstGeom prst="bentConnector2">
             <a:avLst/>
@@ -23845,57 +23698,14 @@
           <p:cNvCxnSpPr>
             <a:cxnSpLocks/>
             <a:stCxn id="33" idx="2"/>
-            <a:endCxn id="30" idx="0"/>
-          </p:cNvCxnSpPr>
-          <p:nvPr/>
-        </p:nvCxnSpPr>
-        <p:spPr>
-          <a:xfrm flipH="1">
-            <a:off x="2383925" y="4201512"/>
-            <a:ext cx="1" cy="247254"/>
-          </a:xfrm>
-          <a:prstGeom prst="straightConnector1">
-            <a:avLst/>
-          </a:prstGeom>
-          <a:ln>
-            <a:tailEnd type="triangle"/>
-          </a:ln>
-        </p:spPr>
-        <p:style>
-          <a:lnRef idx="3">
-            <a:schemeClr val="accent2"/>
-          </a:lnRef>
-          <a:fillRef idx="0">
-            <a:schemeClr val="accent2"/>
-          </a:fillRef>
-          <a:effectRef idx="2">
-            <a:schemeClr val="accent2"/>
-          </a:effectRef>
-          <a:fontRef idx="minor">
-            <a:schemeClr val="tx1"/>
-          </a:fontRef>
-        </p:style>
-      </p:cxnSp>
-      <p:cxnSp>
-        <p:nvCxnSpPr>
-          <p:cNvPr id="67" name="Straight Arrow Connector 66">
-            <a:extLst>
-              <a:ext uri="{FF2B5EF4-FFF2-40B4-BE49-F238E27FC236}">
-                <a16:creationId xmlns:a16="http://schemas.microsoft.com/office/drawing/2014/main" id="{D5F62596-1A1C-01F8-819F-781D9837C64E}"/>
-              </a:ext>
-            </a:extLst>
-          </p:cNvPr>
-          <p:cNvCxnSpPr>
-            <a:cxnSpLocks/>
-            <a:stCxn id="30" idx="2"/>
             <a:endCxn id="37" idx="0"/>
           </p:cNvCxnSpPr>
           <p:nvPr/>
         </p:nvCxnSpPr>
         <p:spPr>
-          <a:xfrm>
-            <a:off x="2383925" y="5412026"/>
-            <a:ext cx="115553" cy="275440"/>
+          <a:xfrm flipH="1">
+            <a:off x="2058522" y="4201512"/>
+            <a:ext cx="325404" cy="481630"/>
           </a:xfrm>
           <a:prstGeom prst="straightConnector1">
             <a:avLst/>
@@ -23937,8 +23747,8 @@
         </p:nvCxnSpPr>
         <p:spPr>
           <a:xfrm flipV="1">
-            <a:off x="4406224" y="5378035"/>
-            <a:ext cx="283667" cy="791061"/>
+            <a:off x="3965268" y="5378035"/>
+            <a:ext cx="724623" cy="259948"/>
           </a:xfrm>
           <a:prstGeom prst="straightConnector1">
             <a:avLst/>
@@ -23974,14 +23784,14 @@
           <p:cNvCxnSpPr>
             <a:cxnSpLocks/>
             <a:stCxn id="41" idx="2"/>
-            <a:endCxn id="48" idx="0"/>
+            <a:endCxn id="45" idx="0"/>
           </p:cNvCxnSpPr>
           <p:nvPr/>
         </p:nvCxnSpPr>
         <p:spPr>
-          <a:xfrm>
-            <a:off x="10682249" y="1641641"/>
-            <a:ext cx="31411" cy="260843"/>
+          <a:xfrm flipH="1">
+            <a:off x="10055772" y="1329926"/>
+            <a:ext cx="626477" cy="4050443"/>
           </a:xfrm>
           <a:prstGeom prst="straightConnector1">
             <a:avLst/>
@@ -24005,92 +23815,6 @@
           </a:fontRef>
         </p:style>
       </p:cxnSp>
-      <p:cxnSp>
-        <p:nvCxnSpPr>
-          <p:cNvPr id="79" name="Straight Arrow Connector 78">
-            <a:extLst>
-              <a:ext uri="{FF2B5EF4-FFF2-40B4-BE49-F238E27FC236}">
-                <a16:creationId xmlns:a16="http://schemas.microsoft.com/office/drawing/2014/main" id="{968D76C4-EBA2-105D-B331-0F7FF417A198}"/>
-              </a:ext>
-            </a:extLst>
-          </p:cNvPr>
-          <p:cNvCxnSpPr>
-            <a:cxnSpLocks/>
-            <a:stCxn id="48" idx="2"/>
-            <a:endCxn id="43" idx="0"/>
-          </p:cNvCxnSpPr>
-          <p:nvPr/>
-        </p:nvCxnSpPr>
-        <p:spPr>
-          <a:xfrm>
-            <a:off x="10713660" y="3400294"/>
-            <a:ext cx="73290" cy="234002"/>
-          </a:xfrm>
-          <a:prstGeom prst="straightConnector1">
-            <a:avLst/>
-          </a:prstGeom>
-          <a:ln>
-            <a:tailEnd type="triangle"/>
-          </a:ln>
-        </p:spPr>
-        <p:style>
-          <a:lnRef idx="3">
-            <a:schemeClr val="accent2"/>
-          </a:lnRef>
-          <a:fillRef idx="0">
-            <a:schemeClr val="accent2"/>
-          </a:fillRef>
-          <a:effectRef idx="2">
-            <a:schemeClr val="accent2"/>
-          </a:effectRef>
-          <a:fontRef idx="minor">
-            <a:schemeClr val="tx1"/>
-          </a:fontRef>
-        </p:style>
-      </p:cxnSp>
-      <p:cxnSp>
-        <p:nvCxnSpPr>
-          <p:cNvPr id="82" name="Straight Arrow Connector 81">
-            <a:extLst>
-              <a:ext uri="{FF2B5EF4-FFF2-40B4-BE49-F238E27FC236}">
-                <a16:creationId xmlns:a16="http://schemas.microsoft.com/office/drawing/2014/main" id="{4CE2A84F-3B15-B4D8-5D1A-8280535D92A8}"/>
-              </a:ext>
-            </a:extLst>
-          </p:cNvPr>
-          <p:cNvCxnSpPr>
-            <a:cxnSpLocks/>
-            <a:stCxn id="43" idx="2"/>
-            <a:endCxn id="45" idx="0"/>
-          </p:cNvCxnSpPr>
-          <p:nvPr/>
-        </p:nvCxnSpPr>
-        <p:spPr>
-          <a:xfrm flipH="1">
-            <a:off x="10055772" y="5132107"/>
-            <a:ext cx="731178" cy="248262"/>
-          </a:xfrm>
-          <a:prstGeom prst="straightConnector1">
-            <a:avLst/>
-          </a:prstGeom>
-          <a:ln>
-            <a:tailEnd type="triangle"/>
-          </a:ln>
-        </p:spPr>
-        <p:style>
-          <a:lnRef idx="3">
-            <a:schemeClr val="accent2"/>
-          </a:lnRef>
-          <a:fillRef idx="0">
-            <a:schemeClr val="accent2"/>
-          </a:fillRef>
-          <a:effectRef idx="2">
-            <a:schemeClr val="accent2"/>
-          </a:effectRef>
-          <a:fontRef idx="minor">
-            <a:schemeClr val="tx1"/>
-          </a:fontRef>
-        </p:style>
-      </p:cxnSp>
       <p:sp>
         <p:nvSpPr>
           <p:cNvPr id="85" name="Rectangle: Rounded Corners 84">
@@ -24106,7 +23830,7 @@
         <p:spPr>
           <a:xfrm>
             <a:off x="4874461" y="5895464"/>
-            <a:ext cx="2743201" cy="820013"/>
+            <a:ext cx="2743201" cy="898935"/>
           </a:xfrm>
           <a:prstGeom prst="roundRect">
             <a:avLst/>
@@ -24133,7 +23857,7 @@
             <a:pPr algn="ctr"/>
             <a:r>
               <a:rPr lang="en-US" sz="1400" dirty="0"/>
-              <a:t>Agents start work</a:t>
+              <a:t>Agents get instructions to fetch  work instructions from MCP server</a:t>
             </a:r>
           </a:p>
           <a:p>
@@ -24171,7 +23895,7 @@
         <p:spPr>
           <a:xfrm flipH="1">
             <a:off x="7617662" y="6064694"/>
-            <a:ext cx="1371601" cy="240777"/>
+            <a:ext cx="1371601" cy="280238"/>
           </a:xfrm>
           <a:prstGeom prst="straightConnector1">
             <a:avLst/>

</xml_diff>